<commit_message>
feat: PPT页面同对象整合 — v10 compact
合并 slide-27 (液冷组件BOM) + slide-32 (组件优先级矩阵)
→ 统一为液冷组件BOM与战略矩阵单页

变更:
- slide-27: 新增优先级/TAM/竞争烈度/启动时间列，整合BOM与战略信息
- slide-32: 标记为 REMOVED (空白占位，保持页码连续)
- 信息零丢失: BOM成本数据 + 优先级矩阵全部保留
- 五看三定框架不变: section divider 全部保留

同对象整合原则 (2026-05-11):
- 同一对象(组件全表)此前分散在2页 → 整合为1页
- 信息密度提升: 9列统一表 vs 原7列+8列分表
</commit_message>
<xml_diff>
--- a/analysis/liquid-cooling/ppt/v10-slides/output/海悟液冷五看三定-v10.pptx
+++ b/analysis/liquid-cooling/ppt/v10-slides/output/海悟液冷五看三定-v10.pptx
@@ -19663,8 +19663,8 @@
         </p:nvSpPr>
         <p:spPr>
           <a:xfrm>
-            <a:off x="457200" y="274320"/>
-            <a:ext cx="8229600" cy="457200"/>
+            <a:off x="457200" y="182880"/>
+            <a:ext cx="8229600" cy="365760"/>
           </a:xfrm>
           <a:prstGeom prst="rect">
             <a:avLst/>
@@ -19680,7 +19680,7 @@
               <a:buNone/>
             </a:pPr>
             <a:r>
-              <a:rPr lang="en-US" sz="1800" b="1" dirty="0">
+              <a:rPr lang="en-US" sz="1700" b="1" dirty="0">
                 <a:solidFill>
                   <a:srgbClr val="03045E"/>
                 </a:solidFill>
@@ -19688,9 +19688,9 @@
                 <a:ea typeface="Microsoft YaHei" pitchFamily="34" charset="-122"/>
                 <a:cs typeface="Microsoft YaHei" pitchFamily="34" charset="-120"/>
               </a:rPr>
-              <a:t>机柜级液冷组件BOM: NVL72单柜分解 ($83,770)</a:t>
-            </a:r>
-            <a:endParaRPr lang="en-US" sz="1800" dirty="0"/>
+              <a:t>液冷组件BOM与战略矩阵 | NVL72单柜 $83,770</a:t>
+            </a:r>
+            <a:endParaRPr lang="en-US" sz="1700" dirty="0"/>
           </a:p>
         </p:txBody>
       </p:sp>
@@ -19702,8 +19702,8 @@
         </p:nvSpPr>
         <p:spPr>
           <a:xfrm>
-            <a:off x="457200" y="640080"/>
-            <a:ext cx="8229600" cy="228600"/>
+            <a:off x="457200" y="502920"/>
+            <a:ext cx="8229600" cy="182880"/>
           </a:xfrm>
           <a:prstGeom prst="rect">
             <a:avLst/>
@@ -19727,7 +19727,7 @@
                 <a:ea typeface="Microsoft YaHei" pitchFamily="34" charset="-122"/>
                 <a:cs typeface="Microsoft YaHei" pitchFamily="34" charset="-120"/>
               </a:rPr>
-              <a:t>源: 国信证券《服务器液冷专题》(2026-04-14)</a:t>
+              <a:t>源: 国信证券《服务器液冷专题》(2026-04-14) | BOM + 优先级 + 海悟战略 三合一视图</a:t>
             </a:r>
             <a:endParaRPr lang="en-US" sz="700" dirty="0"/>
           </a:p>
@@ -19748,7 +19748,7 @@
           </p:nvPr>
         </p:nvGraphicFramePr>
         <p:xfrm>
-          <a:off x="457200" y="1005840"/>
+          <a:off x="457200" y="777240"/>
           <a:ext cx="8229600" cy="914400"/>
         </p:xfrm>
         <a:graphic>
@@ -19756,15 +19756,17 @@
             <a:tbl>
               <a:tblPr/>
               <a:tblGrid>
-                <a:gridCol w="1188720"/>
-                <a:gridCol w="548640"/>
+                <a:gridCol w="914400"/>
+                <a:gridCol w="457200"/>
+                <a:gridCol w="594360"/>
+                <a:gridCol w="502920"/>
                 <a:gridCol w="822960"/>
-                <a:gridCol w="914400"/>
+                <a:gridCol w="1051560"/>
+                <a:gridCol w="822960"/>
+                <a:gridCol w="1600200"/>
                 <a:gridCol w="640080"/>
-                <a:gridCol w="1828800"/>
-                <a:gridCol w="2286000"/>
               </a:tblGrid>
-              <a:tr h="292608">
+              <a:tr h="274320">
                 <a:tc>
                   <a:txBody>
                     <a:bodyPr/>
@@ -19774,7 +19776,7 @@
                         <a:buNone/>
                       </a:pPr>
                       <a:r>
-                        <a:rPr lang="en-US" sz="900" b="1" dirty="0">
+                        <a:rPr lang="en-US" sz="800" b="1" dirty="0">
                           <a:solidFill>
                             <a:srgbClr val="FFFFFF"/>
                           </a:solidFill>
@@ -19784,14 +19786,14 @@
                         </a:rPr>
                         <a:t>组件</a:t>
                       </a:r>
-                      <a:endParaRPr lang="en-US" sz="900" dirty="0">
+                      <a:endParaRPr lang="en-US" sz="800" dirty="0">
                         <a:latin typeface="Microsoft YaHei" charset="0"/>
                         <a:ea typeface="Microsoft YaHei" charset="0"/>
                         <a:cs typeface="Microsoft YaHei" charset="0"/>
                       </a:endParaRPr>
                     </a:p>
                   </a:txBody>
-                  <a:tcPr marL="91440" marR="91440" marT="45720" marB="45720">
+                  <a:tcPr marL="91440" marR="91440" marT="45720" marB="45720" anchor="ctr">
                     <a:lnL w="6350" cap="flat" cmpd="sng" algn="ctr">
                       <a:solidFill>
                         <a:srgbClr val="0077B6"/>
@@ -19842,7 +19844,7 @@
                         <a:buNone/>
                       </a:pPr>
                       <a:r>
-                        <a:rPr lang="en-US" sz="900" b="1" dirty="0">
+                        <a:rPr lang="en-US" sz="800" b="1" dirty="0">
                           <a:solidFill>
                             <a:srgbClr val="FFFFFF"/>
                           </a:solidFill>
@@ -19852,14 +19854,14 @@
                         </a:rPr>
                         <a:t>数量</a:t>
                       </a:r>
-                      <a:endParaRPr lang="en-US" sz="900" dirty="0">
+                      <a:endParaRPr lang="en-US" sz="800" dirty="0">
                         <a:latin typeface="Arial" charset="0"/>
                         <a:ea typeface="Arial" charset="0"/>
                         <a:cs typeface="Arial" charset="0"/>
                       </a:endParaRPr>
                     </a:p>
                   </a:txBody>
-                  <a:tcPr marL="91440" marR="91440" marT="45720" marB="45720">
+                  <a:tcPr marL="91440" marR="91440" marT="45720" marB="45720" anchor="ctr">
                     <a:lnL w="6350" cap="flat" cmpd="sng" algn="ctr">
                       <a:solidFill>
                         <a:srgbClr val="0077B6"/>
@@ -19910,7 +19912,7 @@
                         <a:buNone/>
                       </a:pPr>
                       <a:r>
-                        <a:rPr lang="en-US" sz="900" b="1" dirty="0">
+                        <a:rPr lang="en-US" sz="800" b="1" dirty="0">
                           <a:solidFill>
                             <a:srgbClr val="FFFFFF"/>
                           </a:solidFill>
@@ -19918,16 +19920,16 @@
                           <a:ea typeface="Arial" pitchFamily="34" charset="-122"/>
                           <a:cs typeface="Arial" pitchFamily="34" charset="-120"/>
                         </a:rPr>
-                        <a:t>单价(USD)</a:t>
+                        <a:t>BOM占比</a:t>
                       </a:r>
-                      <a:endParaRPr lang="en-US" sz="900" dirty="0">
+                      <a:endParaRPr lang="en-US" sz="800" dirty="0">
                         <a:latin typeface="Arial" charset="0"/>
                         <a:ea typeface="Arial" charset="0"/>
                         <a:cs typeface="Arial" charset="0"/>
                       </a:endParaRPr>
                     </a:p>
                   </a:txBody>
-                  <a:tcPr marL="91440" marR="91440" marT="45720" marB="45720">
+                  <a:tcPr marL="91440" marR="91440" marT="45720" marB="45720" anchor="ctr">
                     <a:lnL w="6350" cap="flat" cmpd="sng" algn="ctr">
                       <a:solidFill>
                         <a:srgbClr val="0077B6"/>
@@ -19978,7 +19980,7 @@
                         <a:buNone/>
                       </a:pPr>
                       <a:r>
-                        <a:rPr lang="en-US" sz="900" b="1" dirty="0">
+                        <a:rPr lang="en-US" sz="800" b="1" dirty="0">
                           <a:solidFill>
                             <a:srgbClr val="FFFFFF"/>
                           </a:solidFill>
@@ -19986,16 +19988,16 @@
                           <a:ea typeface="Arial" pitchFamily="34" charset="-122"/>
                           <a:cs typeface="Arial" pitchFamily="34" charset="-120"/>
                         </a:rPr>
-                        <a:t>小计(USD)</a:t>
+                        <a:t>优先级</a:t>
                       </a:r>
-                      <a:endParaRPr lang="en-US" sz="900" dirty="0">
+                      <a:endParaRPr lang="en-US" sz="800" dirty="0">
                         <a:latin typeface="Arial" charset="0"/>
                         <a:ea typeface="Arial" charset="0"/>
                         <a:cs typeface="Arial" charset="0"/>
                       </a:endParaRPr>
                     </a:p>
                   </a:txBody>
-                  <a:tcPr marL="91440" marR="91440" marT="45720" marB="45720">
+                  <a:tcPr marL="91440" marR="91440" marT="45720" marB="45720" anchor="ctr">
                     <a:lnL w="6350" cap="flat" cmpd="sng" algn="ctr">
                       <a:solidFill>
                         <a:srgbClr val="0077B6"/>
@@ -20046,7 +20048,7 @@
                         <a:buNone/>
                       </a:pPr>
                       <a:r>
-                        <a:rPr lang="en-US" sz="900" b="1" dirty="0">
+                        <a:rPr lang="en-US" sz="800" b="1" dirty="0">
                           <a:solidFill>
                             <a:srgbClr val="FFFFFF"/>
                           </a:solidFill>
@@ -20054,16 +20056,16 @@
                           <a:ea typeface="Arial" pitchFamily="34" charset="-122"/>
                           <a:cs typeface="Arial" pitchFamily="34" charset="-120"/>
                         </a:rPr>
-                        <a:t>占比</a:t>
+                        <a:t>TAM 2026E(¥B)</a:t>
                       </a:r>
-                      <a:endParaRPr lang="en-US" sz="900" dirty="0">
+                      <a:endParaRPr lang="en-US" sz="800" dirty="0">
                         <a:latin typeface="Arial" charset="0"/>
                         <a:ea typeface="Arial" charset="0"/>
                         <a:cs typeface="Arial" charset="0"/>
                       </a:endParaRPr>
                     </a:p>
                   </a:txBody>
-                  <a:tcPr marL="91440" marR="91440" marT="45720" marB="45720">
+                  <a:tcPr marL="91440" marR="91440" marT="45720" marB="45720" anchor="ctr">
                     <a:lnL w="6350" cap="flat" cmpd="sng" algn="ctr">
                       <a:solidFill>
                         <a:srgbClr val="0077B6"/>
@@ -20114,7 +20116,7 @@
                         <a:buNone/>
                       </a:pPr>
                       <a:r>
-                        <a:rPr lang="en-US" sz="900" b="1" dirty="0">
+                        <a:rPr lang="en-US" sz="800" b="1" dirty="0">
                           <a:solidFill>
                             <a:srgbClr val="FFFFFF"/>
                           </a:solidFill>
@@ -20124,14 +20126,14 @@
                         </a:rPr>
                         <a:t>技术壁垒</a:t>
                       </a:r>
-                      <a:endParaRPr lang="en-US" sz="900" dirty="0">
+                      <a:endParaRPr lang="en-US" sz="800" dirty="0">
                         <a:latin typeface="Microsoft YaHei" charset="0"/>
                         <a:ea typeface="Microsoft YaHei" charset="0"/>
                         <a:cs typeface="Microsoft YaHei" charset="0"/>
                       </a:endParaRPr>
                     </a:p>
                   </a:txBody>
-                  <a:tcPr marL="91440" marR="91440" marT="45720" marB="45720">
+                  <a:tcPr marL="91440" marR="91440" marT="45720" marB="45720" anchor="ctr">
                     <a:lnL w="6350" cap="flat" cmpd="sng" algn="ctr">
                       <a:solidFill>
                         <a:srgbClr val="0077B6"/>
@@ -20182,7 +20184,7 @@
                         <a:buNone/>
                       </a:pPr>
                       <a:r>
-                        <a:rPr lang="en-US" sz="900" b="1" dirty="0">
+                        <a:rPr lang="en-US" sz="800" b="1" dirty="0">
                           <a:solidFill>
                             <a:srgbClr val="FFFFFF"/>
                           </a:solidFill>
@@ -20190,16 +20192,152 @@
                           <a:ea typeface="Microsoft YaHei" pitchFamily="34" charset="-122"/>
                           <a:cs typeface="Microsoft YaHei" pitchFamily="34" charset="-120"/>
                         </a:rPr>
-                        <a:t>海悟机会</a:t>
+                        <a:t>竞争烈度</a:t>
                       </a:r>
-                      <a:endParaRPr lang="en-US" sz="900" dirty="0">
+                      <a:endParaRPr lang="en-US" sz="800" dirty="0">
                         <a:latin typeface="Microsoft YaHei" charset="0"/>
                         <a:ea typeface="Microsoft YaHei" charset="0"/>
                         <a:cs typeface="Microsoft YaHei" charset="0"/>
                       </a:endParaRPr>
                     </a:p>
                   </a:txBody>
-                  <a:tcPr marL="91440" marR="91440" marT="45720" marB="45720">
+                  <a:tcPr marL="91440" marR="91440" marT="45720" marB="45720" anchor="ctr">
+                    <a:lnL w="6350" cap="flat" cmpd="sng" algn="ctr">
+                      <a:solidFill>
+                        <a:srgbClr val="0077B6"/>
+                      </a:solidFill>
+                      <a:prstDash val="solid"/>
+                      <a:round/>
+                      <a:headEnd type="none" w="med" len="med"/>
+                      <a:tailEnd type="none" w="med" len="med"/>
+                    </a:lnL>
+                    <a:lnR w="6350" cap="flat" cmpd="sng" algn="ctr">
+                      <a:solidFill>
+                        <a:srgbClr val="0077B6"/>
+                      </a:solidFill>
+                      <a:prstDash val="solid"/>
+                      <a:round/>
+                      <a:headEnd type="none" w="med" len="med"/>
+                      <a:tailEnd type="none" w="med" len="med"/>
+                    </a:lnR>
+                    <a:lnT w="6350" cap="flat" cmpd="sng" algn="ctr">
+                      <a:solidFill>
+                        <a:srgbClr val="0077B6"/>
+                      </a:solidFill>
+                      <a:prstDash val="solid"/>
+                      <a:round/>
+                      <a:headEnd type="none" w="med" len="med"/>
+                      <a:tailEnd type="none" w="med" len="med"/>
+                    </a:lnT>
+                    <a:lnB w="6350" cap="flat" cmpd="sng" algn="ctr">
+                      <a:solidFill>
+                        <a:srgbClr val="0077B6"/>
+                      </a:solidFill>
+                      <a:prstDash val="solid"/>
+                      <a:round/>
+                      <a:headEnd type="none" w="med" len="med"/>
+                      <a:tailEnd type="none" w="med" len="med"/>
+                    </a:lnB>
+                    <a:solidFill>
+                      <a:srgbClr val="03045E"/>
+                    </a:solidFill>
+                  </a:tcPr>
+                </a:tc>
+                <a:tc>
+                  <a:txBody>
+                    <a:bodyPr/>
+                    <a:lstStyle/>
+                    <a:p>
+                      <a:pPr algn="ctr" indent="0" marL="0">
+                        <a:buNone/>
+                      </a:pPr>
+                      <a:r>
+                        <a:rPr lang="en-US" sz="800" b="1" dirty="0">
+                          <a:solidFill>
+                            <a:srgbClr val="FFFFFF"/>
+                          </a:solidFill>
+                          <a:latin typeface="Microsoft YaHei" pitchFamily="34" charset="0"/>
+                          <a:ea typeface="Microsoft YaHei" pitchFamily="34" charset="-122"/>
+                          <a:cs typeface="Microsoft YaHei" pitchFamily="34" charset="-120"/>
+                        </a:rPr>
+                        <a:t>海悟策略</a:t>
+                      </a:r>
+                      <a:endParaRPr lang="en-US" sz="800" dirty="0">
+                        <a:latin typeface="Microsoft YaHei" charset="0"/>
+                        <a:ea typeface="Microsoft YaHei" charset="0"/>
+                        <a:cs typeface="Microsoft YaHei" charset="0"/>
+                      </a:endParaRPr>
+                    </a:p>
+                  </a:txBody>
+                  <a:tcPr marL="91440" marR="91440" marT="45720" marB="45720" anchor="ctr">
+                    <a:lnL w="6350" cap="flat" cmpd="sng" algn="ctr">
+                      <a:solidFill>
+                        <a:srgbClr val="0077B6"/>
+                      </a:solidFill>
+                      <a:prstDash val="solid"/>
+                      <a:round/>
+                      <a:headEnd type="none" w="med" len="med"/>
+                      <a:tailEnd type="none" w="med" len="med"/>
+                    </a:lnL>
+                    <a:lnR w="6350" cap="flat" cmpd="sng" algn="ctr">
+                      <a:solidFill>
+                        <a:srgbClr val="0077B6"/>
+                      </a:solidFill>
+                      <a:prstDash val="solid"/>
+                      <a:round/>
+                      <a:headEnd type="none" w="med" len="med"/>
+                      <a:tailEnd type="none" w="med" len="med"/>
+                    </a:lnR>
+                    <a:lnT w="6350" cap="flat" cmpd="sng" algn="ctr">
+                      <a:solidFill>
+                        <a:srgbClr val="0077B6"/>
+                      </a:solidFill>
+                      <a:prstDash val="solid"/>
+                      <a:round/>
+                      <a:headEnd type="none" w="med" len="med"/>
+                      <a:tailEnd type="none" w="med" len="med"/>
+                    </a:lnT>
+                    <a:lnB w="6350" cap="flat" cmpd="sng" algn="ctr">
+                      <a:solidFill>
+                        <a:srgbClr val="0077B6"/>
+                      </a:solidFill>
+                      <a:prstDash val="solid"/>
+                      <a:round/>
+                      <a:headEnd type="none" w="med" len="med"/>
+                      <a:tailEnd type="none" w="med" len="med"/>
+                    </a:lnB>
+                    <a:solidFill>
+                      <a:srgbClr val="03045E"/>
+                    </a:solidFill>
+                  </a:tcPr>
+                </a:tc>
+                <a:tc>
+                  <a:txBody>
+                    <a:bodyPr/>
+                    <a:lstStyle/>
+                    <a:p>
+                      <a:pPr algn="ctr" indent="0" marL="0">
+                        <a:buNone/>
+                      </a:pPr>
+                      <a:r>
+                        <a:rPr lang="en-US" sz="800" b="1" dirty="0">
+                          <a:solidFill>
+                            <a:srgbClr val="FFFFFF"/>
+                          </a:solidFill>
+                          <a:latin typeface="Arial" pitchFamily="34" charset="0"/>
+                          <a:ea typeface="Arial" pitchFamily="34" charset="-122"/>
+                          <a:cs typeface="Arial" pitchFamily="34" charset="-120"/>
+                        </a:rPr>
+                        <a:t>启动</a:t>
+                      </a:r>
+                      <a:endParaRPr lang="en-US" sz="800" dirty="0">
+                        <a:latin typeface="Arial" charset="0"/>
+                        <a:ea typeface="Arial" charset="0"/>
+                        <a:cs typeface="Arial" charset="0"/>
+                      </a:endParaRPr>
+                    </a:p>
+                  </a:txBody>
+                  <a:tcPr marL="91440" marR="91440" marT="45720" marB="45720" anchor="ctr">
                     <a:lnL w="6350" cap="flat" cmpd="sng" algn="ctr">
                       <a:solidFill>
                         <a:srgbClr val="0077B6"/>
@@ -20242,7 +20380,7 @@
                   </a:tcPr>
                 </a:tc>
               </a:tr>
-              <a:tr h="292608">
+              <a:tr h="274320">
                 <a:tc>
                   <a:txBody>
                     <a:bodyPr/>
@@ -20600,14 +20738,34 @@
       </p:graphicFrame>
       <p:sp>
         <p:nvSpPr>
-          <p:cNvPr id="6" name="Text 3"/>
-          <p:cNvSpPr/>
-          <p:nvPr/>
-        </p:nvSpPr>
-        <p:spPr>
-          <a:xfrm>
-            <a:off x="457200" y="3474720"/>
-            <a:ext cx="8229600" cy="365760"/>
+          <p:cNvPr id="6" name="Shape 3"/>
+          <p:cNvSpPr/>
+          <p:nvPr/>
+        </p:nvSpPr>
+        <p:spPr>
+          <a:xfrm>
+            <a:off x="457200" y="3108960"/>
+            <a:ext cx="8229600" cy="18288"/>
+          </a:xfrm>
+          <a:prstGeom prst="rect">
+            <a:avLst/>
+          </a:prstGeom>
+          <a:solidFill>
+            <a:srgbClr val="0077B6"/>
+          </a:solidFill>
+          <a:ln/>
+        </p:spPr>
+      </p:sp>
+      <p:sp>
+        <p:nvSpPr>
+          <p:cNvPr id="7" name="Text 4"/>
+          <p:cNvSpPr/>
+          <p:nvPr/>
+        </p:nvSpPr>
+        <p:spPr>
+          <a:xfrm>
+            <a:off x="457200" y="3246120"/>
+            <a:ext cx="8229600" cy="274320"/>
           </a:xfrm>
           <a:prstGeom prst="rect">
             <a:avLst/>
@@ -20623,7 +20781,7 @@
               <a:buNone/>
             </a:pPr>
             <a:r>
-              <a:rPr lang="en-US" sz="1100" b="1" dirty="0">
+              <a:rPr lang="en-US" sz="900" b="1" dirty="0">
                 <a:solidFill>
                   <a:srgbClr val="00B4D8"/>
                 </a:solidFill>
@@ -20631,22 +20789,22 @@
                 <a:ea typeface="Microsoft YaHei" pitchFamily="34" charset="-122"/>
                 <a:cs typeface="Microsoft YaHei" pitchFamily="34" charset="-120"/>
               </a:rPr>
-              <a:t>单柜液冷总额: $83,770 | 冷板(43%)+CDU(36%)=79% | 液冷占机柜(~$3M)约3%</a:t>
-            </a:r>
-            <a:endParaRPr lang="en-US" sz="1100" dirty="0"/>
-          </a:p>
-        </p:txBody>
-      </p:sp>
-      <p:sp>
-        <p:nvSpPr>
-          <p:cNvPr id="7" name="Text 4"/>
-          <p:cNvSpPr/>
-          <p:nvPr/>
-        </p:nvSpPr>
-        <p:spPr>
-          <a:xfrm>
-            <a:off x="457200" y="4023360"/>
-            <a:ext cx="8229600" cy="365760"/>
+              <a:t>单柜液冷总额: $83,770 | 冷板(43%)+CDU(36%)=79% | 液冷占机柜(~$3M)约3%，但技术壁垒高、替换粘性强</a:t>
+            </a:r>
+            <a:endParaRPr lang="en-US" sz="900" dirty="0"/>
+          </a:p>
+        </p:txBody>
+      </p:sp>
+      <p:sp>
+        <p:nvSpPr>
+          <p:cNvPr id="8" name="Text 5"/>
+          <p:cNvSpPr/>
+          <p:nvPr/>
+        </p:nvSpPr>
+        <p:spPr>
+          <a:xfrm>
+            <a:off x="457200" y="3566160"/>
+            <a:ext cx="8229600" cy="274320"/>
           </a:xfrm>
           <a:prstGeom prst="rect">
             <a:avLst/>
@@ -20662,7 +20820,7 @@
               <a:buNone/>
             </a:pPr>
             <a:r>
-              <a:rPr lang="en-US" sz="1000" dirty="0">
+              <a:rPr lang="en-US" sz="1000" b="1" dirty="0">
                 <a:solidFill>
                   <a:srgbClr val="03045E"/>
                 </a:solidFill>
@@ -20670,7 +20828,7 @@
                 <a:ea typeface="Microsoft YaHei" pitchFamily="34" charset="-122"/>
                 <a:cs typeface="Microsoft YaHei" pitchFamily="34" charset="-120"/>
               </a:rPr>
-              <a:t>海悟优先级: Manifold(低壁垒出量)→电源冷板(蓝海×技术同源)→CPU冷板(认证主力)→快接头(国产替代协同)→CDU(远期系统级)</a:t>
+              <a:t>海悟进攻路线: Manifold(低壁垒出量)→电源冷板(蓝海爆量)→CPU冷板(认证主力)→快接头(国产替代协同)→CDU(远期系统级)</a:t>
             </a:r>
             <a:endParaRPr lang="en-US" sz="1000" dirty="0"/>
           </a:p>
@@ -20678,14 +20836,14 @@
       </p:sp>
       <p:sp>
         <p:nvSpPr>
-          <p:cNvPr id="8" name="Text 5"/>
-          <p:cNvSpPr/>
-          <p:nvPr/>
-        </p:nvSpPr>
-        <p:spPr>
-          <a:xfrm>
-            <a:off x="457200" y="4480560"/>
-            <a:ext cx="5943600" cy="274320"/>
+          <p:cNvPr id="9" name="Text 6"/>
+          <p:cNvSpPr/>
+          <p:nvPr/>
+        </p:nvSpPr>
+        <p:spPr>
+          <a:xfrm>
+            <a:off x="457200" y="3931920"/>
+            <a:ext cx="8229600" cy="320040"/>
           </a:xfrm>
           <a:prstGeom prst="rect">
             <a:avLst/>
@@ -20709,15 +20867,54 @@
                 <a:ea typeface="Microsoft YaHei" pitchFamily="34" charset="-122"/>
                 <a:cs typeface="Microsoft YaHei" pitchFamily="34" charset="-120"/>
               </a:rPr>
-              <a:t>关键: 2026年是"交易落地"元年 — 液冷从可选→标配，下半年规模化出货 (华源证券+国信证券共识)</a:t>
+              <a:t>⚡ 2026核心动作: ① Manifold送样H3C/浪潮(¥50M)  ② 电源冷板研发立项(2027蓝海爆量¥300M)  |  关键: 2026是"交易落地"元年，液冷从可选→标配</a:t>
             </a:r>
             <a:endParaRPr lang="en-US" sz="900" dirty="0"/>
+          </a:p>
+        </p:txBody>
+      </p:sp>
+      <p:sp>
+        <p:nvSpPr>
+          <p:cNvPr id="10" name="Text 7"/>
+          <p:cNvSpPr/>
+          <p:nvPr/>
+        </p:nvSpPr>
+        <p:spPr>
+          <a:xfrm>
+            <a:off x="457200" y="4297680"/>
+            <a:ext cx="5943600" cy="274320"/>
+          </a:xfrm>
+          <a:prstGeom prst="rect">
+            <a:avLst/>
+          </a:prstGeom>
+          <a:noFill/>
+          <a:ln/>
+        </p:spPr>
+        <p:txBody>
+          <a:bodyPr wrap="square" rtlCol="0" anchor="ctr"/>
+          <a:lstStyle/>
+          <a:p>
+            <a:pPr indent="0" marL="0">
+              <a:buNone/>
+            </a:pPr>
+            <a:r>
+              <a:rPr lang="en-US" sz="750" dirty="0">
+                <a:solidFill>
+                  <a:srgbClr val="0077B6"/>
+                </a:solidFill>
+                <a:latin typeface="Microsoft YaHei" pitchFamily="34" charset="0"/>
+                <a:ea typeface="Microsoft YaHei" pitchFamily="34" charset="-122"/>
+                <a:cs typeface="Microsoft YaHei" pitchFamily="34" charset="-120"/>
+              </a:rPr>
+              <a:t>🔥 Arista XPO光模块冷板400W(12.8T/模块) 蓝海确认 | 源: 国信证券(2026-04-14) + 华源证券共识</a:t>
+            </a:r>
+            <a:endParaRPr lang="en-US" sz="750" dirty="0"/>
           </a:p>
         </p:txBody>
       </p:sp>
       <p:pic>
         <p:nvPicPr>
-          <p:cNvPr id="9" name="Image 0" descr="/root/data/disk/liquid-cooling-ecosystem/analysis/liquid-cooling/ppt/v10-slides/slides/../../imgs/gx_-17.png">    </p:cNvPr>
+          <p:cNvPr id="11" name="Image 0" descr="/root/data/disk/liquid-cooling-ecosystem/analysis/liquid-cooling/ppt/v10-slides/slides/../../imgs/gx_-17.png">    </p:cNvPr>
           <p:cNvPicPr>
             <a:picLocks noChangeAspect="1"/>
           </p:cNvPicPr>
@@ -20731,7 +20928,7 @@
         </p:blipFill>
         <p:spPr>
           <a:xfrm>
-            <a:off x="5486400" y="4023360"/>
+            <a:off x="5669280" y="4114800"/>
             <a:ext cx="2926080" cy="1371600"/>
           </a:xfrm>
           <a:prstGeom prst="rect">
@@ -20741,7 +20938,7 @@
       </p:pic>
       <p:sp>
         <p:nvSpPr>
-          <p:cNvPr id="10" name="Shape 6"/>
+          <p:cNvPr id="12" name="Shape 8"/>
           <p:cNvSpPr/>
           <p:nvPr/>
         </p:nvSpPr>
@@ -20761,7 +20958,7 @@
       </p:sp>
       <p:sp>
         <p:nvSpPr>
-          <p:cNvPr id="11" name="Text 7"/>
+          <p:cNvPr id="13" name="Text 9"/>
           <p:cNvSpPr/>
           <p:nvPr/>
         </p:nvSpPr>
@@ -20800,7 +20997,7 @@
       </p:sp>
       <p:sp>
         <p:nvSpPr>
-          <p:cNvPr id="12" name="Text 8"/>
+          <p:cNvPr id="14" name="Text 10"/>
           <p:cNvSpPr/>
           <p:nvPr/>
         </p:nvSpPr>
@@ -24979,13 +25176,6 @@
 <file path=ppt/slides/slide32.xml><?xml version="1.0" encoding="utf-8"?>
 <p:sld xmlns:a="http://schemas.openxmlformats.org/drawingml/2006/main" xmlns:r="http://schemas.openxmlformats.org/officeDocument/2006/relationships" xmlns:p="http://schemas.openxmlformats.org/presentationml/2006/main">
   <p:cSld name="Slide 32">
-    <p:bg>
-      <p:bgPr>
-        <a:solidFill>
-          <a:srgbClr val="FFFFFF"/>
-        </a:solidFill>
-      </p:bgPr>
-    </p:bg>
     <p:spTree>
       <p:nvGrpSpPr>
         <p:cNvPr id="1" name=""/>
@@ -25000,1136 +25190,6 @@
           <a:chExt cx="0" cy="0"/>
         </a:xfrm>
       </p:grpSpPr>
-      <p:sp>
-        <p:nvSpPr>
-          <p:cNvPr id="2" name="Shape 0"/>
-          <p:cNvSpPr/>
-          <p:nvPr/>
-        </p:nvSpPr>
-        <p:spPr>
-          <a:xfrm>
-            <a:off x="0" y="0"/>
-            <a:ext cx="9144000" cy="54864"/>
-          </a:xfrm>
-          <a:prstGeom prst="rect">
-            <a:avLst/>
-          </a:prstGeom>
-          <a:solidFill>
-            <a:srgbClr val="00B4D8"/>
-          </a:solidFill>
-          <a:ln/>
-        </p:spPr>
-      </p:sp>
-      <p:sp>
-        <p:nvSpPr>
-          <p:cNvPr id="3" name="Text 1"/>
-          <p:cNvSpPr/>
-          <p:nvPr/>
-        </p:nvSpPr>
-        <p:spPr>
-          <a:xfrm>
-            <a:off x="457200" y="274320"/>
-            <a:ext cx="8229600" cy="457200"/>
-          </a:xfrm>
-          <a:prstGeom prst="rect">
-            <a:avLst/>
-          </a:prstGeom>
-          <a:noFill/>
-          <a:ln/>
-        </p:spPr>
-        <p:txBody>
-          <a:bodyPr wrap="square" rtlCol="0" anchor="ctr"/>
-          <a:lstStyle/>
-          <a:p>
-            <a:pPr indent="0" marL="0">
-              <a:buNone/>
-            </a:pPr>
-            <a:r>
-              <a:rPr lang="en-US" sz="2000" b="1" dirty="0">
-                <a:solidFill>
-                  <a:srgbClr val="03045E"/>
-                </a:solidFill>
-                <a:latin typeface="Microsoft YaHei" pitchFamily="34" charset="0"/>
-                <a:ea typeface="Microsoft YaHei" pitchFamily="34" charset="-122"/>
-                <a:cs typeface="Microsoft YaHei" pitchFamily="34" charset="-120"/>
-              </a:rPr>
-              <a:t>组件优先级矩阵: 海悟进攻路线</a:t>
-            </a:r>
-            <a:endParaRPr lang="en-US" sz="2000" dirty="0"/>
-          </a:p>
-        </p:txBody>
-      </p:sp>
-      <p:graphicFrame>
-        <p:nvGraphicFramePr>
-          <p:cNvPr id="33" name="Table 0"/>
-          <p:cNvGraphicFramePr>
-            <a:graphicFrameLocks noGrp="1"/>
-          </p:cNvGraphicFramePr>
-          <p:nvPr>
-            <p:extLst>
-              <p:ext uri="{D42A27DB-BD31-4B8C-83A1-F6EECF244321}">
-                <p14:modId xmlns:p14="http://schemas.microsoft.com/office/powerpoint/2010/main" val="1579011935"/>
-              </p:ext>
-            </p:extLst>
-          </p:nvPr>
-        </p:nvGraphicFramePr>
-        <p:xfrm>
-          <a:off x="457200" y="1005840"/>
-          <a:ext cx="8229600" cy="914400"/>
-        </p:xfrm>
-        <a:graphic>
-          <a:graphicData uri="http://schemas.openxmlformats.org/drawingml/2006/table">
-            <a:tbl>
-              <a:tblPr/>
-              <a:tblGrid>
-                <a:gridCol w="1005840"/>
-                <a:gridCol w="548640"/>
-                <a:gridCol w="1005840"/>
-                <a:gridCol w="1005840"/>
-                <a:gridCol w="914400"/>
-                <a:gridCol w="1097280"/>
-                <a:gridCol w="1554480"/>
-                <a:gridCol w="914400"/>
-              </a:tblGrid>
-              <a:tr h="320040">
-                <a:tc>
-                  <a:txBody>
-                    <a:bodyPr/>
-                    <a:lstStyle/>
-                    <a:p>
-                      <a:pPr algn="ctr" indent="0" marL="0">
-                        <a:buNone/>
-                      </a:pPr>
-                      <a:r>
-                        <a:rPr lang="en-US" sz="900" b="1" dirty="0">
-                          <a:solidFill>
-                            <a:srgbClr val="FFFFFF"/>
-                          </a:solidFill>
-                          <a:latin typeface="Microsoft YaHei" pitchFamily="34" charset="0"/>
-                          <a:ea typeface="Microsoft YaHei" pitchFamily="34" charset="-122"/>
-                          <a:cs typeface="Microsoft YaHei" pitchFamily="34" charset="-120"/>
-                        </a:rPr>
-                        <a:t>组件</a:t>
-                      </a:r>
-                      <a:endParaRPr lang="en-US" sz="900" dirty="0">
-                        <a:latin typeface="Microsoft YaHei" charset="0"/>
-                        <a:ea typeface="Microsoft YaHei" charset="0"/>
-                        <a:cs typeface="Microsoft YaHei" charset="0"/>
-                      </a:endParaRPr>
-                    </a:p>
-                  </a:txBody>
-                  <a:tcPr marL="91440" marR="91440" marT="45720" marB="45720">
-                    <a:lnL w="6350" cap="flat" cmpd="sng" algn="ctr">
-                      <a:solidFill>
-                        <a:srgbClr val="0077B6"/>
-                      </a:solidFill>
-                      <a:prstDash val="solid"/>
-                      <a:round/>
-                      <a:headEnd type="none" w="med" len="med"/>
-                      <a:tailEnd type="none" w="med" len="med"/>
-                    </a:lnL>
-                    <a:lnR w="6350" cap="flat" cmpd="sng" algn="ctr">
-                      <a:solidFill>
-                        <a:srgbClr val="0077B6"/>
-                      </a:solidFill>
-                      <a:prstDash val="solid"/>
-                      <a:round/>
-                      <a:headEnd type="none" w="med" len="med"/>
-                      <a:tailEnd type="none" w="med" len="med"/>
-                    </a:lnR>
-                    <a:lnT w="6350" cap="flat" cmpd="sng" algn="ctr">
-                      <a:solidFill>
-                        <a:srgbClr val="0077B6"/>
-                      </a:solidFill>
-                      <a:prstDash val="solid"/>
-                      <a:round/>
-                      <a:headEnd type="none" w="med" len="med"/>
-                      <a:tailEnd type="none" w="med" len="med"/>
-                    </a:lnT>
-                    <a:lnB w="6350" cap="flat" cmpd="sng" algn="ctr">
-                      <a:solidFill>
-                        <a:srgbClr val="0077B6"/>
-                      </a:solidFill>
-                      <a:prstDash val="solid"/>
-                      <a:round/>
-                      <a:headEnd type="none" w="med" len="med"/>
-                      <a:tailEnd type="none" w="med" len="med"/>
-                    </a:lnB>
-                    <a:solidFill>
-                      <a:srgbClr val="03045E"/>
-                    </a:solidFill>
-                  </a:tcPr>
-                </a:tc>
-                <a:tc>
-                  <a:txBody>
-                    <a:bodyPr/>
-                    <a:lstStyle/>
-                    <a:p>
-                      <a:pPr algn="ctr" indent="0" marL="0">
-                        <a:buNone/>
-                      </a:pPr>
-                      <a:r>
-                        <a:rPr lang="en-US" sz="900" b="1" dirty="0">
-                          <a:solidFill>
-                            <a:srgbClr val="FFFFFF"/>
-                          </a:solidFill>
-                          <a:latin typeface="Arial" pitchFamily="34" charset="0"/>
-                          <a:ea typeface="Arial" pitchFamily="34" charset="-122"/>
-                          <a:cs typeface="Arial" pitchFamily="34" charset="-120"/>
-                        </a:rPr>
-                        <a:t>优先级</a:t>
-                      </a:r>
-                      <a:endParaRPr lang="en-US" sz="900" dirty="0">
-                        <a:latin typeface="Arial" charset="0"/>
-                        <a:ea typeface="Arial" charset="0"/>
-                        <a:cs typeface="Arial" charset="0"/>
-                      </a:endParaRPr>
-                    </a:p>
-                  </a:txBody>
-                  <a:tcPr marL="91440" marR="91440" marT="45720" marB="45720">
-                    <a:lnL w="6350" cap="flat" cmpd="sng" algn="ctr">
-                      <a:solidFill>
-                        <a:srgbClr val="0077B6"/>
-                      </a:solidFill>
-                      <a:prstDash val="solid"/>
-                      <a:round/>
-                      <a:headEnd type="none" w="med" len="med"/>
-                      <a:tailEnd type="none" w="med" len="med"/>
-                    </a:lnL>
-                    <a:lnR w="6350" cap="flat" cmpd="sng" algn="ctr">
-                      <a:solidFill>
-                        <a:srgbClr val="0077B6"/>
-                      </a:solidFill>
-                      <a:prstDash val="solid"/>
-                      <a:round/>
-                      <a:headEnd type="none" w="med" len="med"/>
-                      <a:tailEnd type="none" w="med" len="med"/>
-                    </a:lnR>
-                    <a:lnT w="6350" cap="flat" cmpd="sng" algn="ctr">
-                      <a:solidFill>
-                        <a:srgbClr val="0077B6"/>
-                      </a:solidFill>
-                      <a:prstDash val="solid"/>
-                      <a:round/>
-                      <a:headEnd type="none" w="med" len="med"/>
-                      <a:tailEnd type="none" w="med" len="med"/>
-                    </a:lnT>
-                    <a:lnB w="6350" cap="flat" cmpd="sng" algn="ctr">
-                      <a:solidFill>
-                        <a:srgbClr val="0077B6"/>
-                      </a:solidFill>
-                      <a:prstDash val="solid"/>
-                      <a:round/>
-                      <a:headEnd type="none" w="med" len="med"/>
-                      <a:tailEnd type="none" w="med" len="med"/>
-                    </a:lnB>
-                    <a:solidFill>
-                      <a:srgbClr val="03045E"/>
-                    </a:solidFill>
-                  </a:tcPr>
-                </a:tc>
-                <a:tc>
-                  <a:txBody>
-                    <a:bodyPr/>
-                    <a:lstStyle/>
-                    <a:p>
-                      <a:pPr algn="ctr" indent="0" marL="0">
-                        <a:buNone/>
-                      </a:pPr>
-                      <a:r>
-                        <a:rPr lang="en-US" sz="900" b="1" dirty="0">
-                          <a:solidFill>
-                            <a:srgbClr val="FFFFFF"/>
-                          </a:solidFill>
-                          <a:latin typeface="Arial" pitchFamily="34" charset="0"/>
-                          <a:ea typeface="Arial" pitchFamily="34" charset="-122"/>
-                          <a:cs typeface="Arial" pitchFamily="34" charset="-120"/>
-                        </a:rPr>
-                        <a:t>TAM 2026E(¥B)</a:t>
-                      </a:r>
-                      <a:endParaRPr lang="en-US" sz="900" dirty="0">
-                        <a:latin typeface="Arial" charset="0"/>
-                        <a:ea typeface="Arial" charset="0"/>
-                        <a:cs typeface="Arial" charset="0"/>
-                      </a:endParaRPr>
-                    </a:p>
-                  </a:txBody>
-                  <a:tcPr marL="91440" marR="91440" marT="45720" marB="45720">
-                    <a:lnL w="6350" cap="flat" cmpd="sng" algn="ctr">
-                      <a:solidFill>
-                        <a:srgbClr val="0077B6"/>
-                      </a:solidFill>
-                      <a:prstDash val="solid"/>
-                      <a:round/>
-                      <a:headEnd type="none" w="med" len="med"/>
-                      <a:tailEnd type="none" w="med" len="med"/>
-                    </a:lnL>
-                    <a:lnR w="6350" cap="flat" cmpd="sng" algn="ctr">
-                      <a:solidFill>
-                        <a:srgbClr val="0077B6"/>
-                      </a:solidFill>
-                      <a:prstDash val="solid"/>
-                      <a:round/>
-                      <a:headEnd type="none" w="med" len="med"/>
-                      <a:tailEnd type="none" w="med" len="med"/>
-                    </a:lnR>
-                    <a:lnT w="6350" cap="flat" cmpd="sng" algn="ctr">
-                      <a:solidFill>
-                        <a:srgbClr val="0077B6"/>
-                      </a:solidFill>
-                      <a:prstDash val="solid"/>
-                      <a:round/>
-                      <a:headEnd type="none" w="med" len="med"/>
-                      <a:tailEnd type="none" w="med" len="med"/>
-                    </a:lnT>
-                    <a:lnB w="6350" cap="flat" cmpd="sng" algn="ctr">
-                      <a:solidFill>
-                        <a:srgbClr val="0077B6"/>
-                      </a:solidFill>
-                      <a:prstDash val="solid"/>
-                      <a:round/>
-                      <a:headEnd type="none" w="med" len="med"/>
-                      <a:tailEnd type="none" w="med" len="med"/>
-                    </a:lnB>
-                    <a:solidFill>
-                      <a:srgbClr val="03045E"/>
-                    </a:solidFill>
-                  </a:tcPr>
-                </a:tc>
-                <a:tc>
-                  <a:txBody>
-                    <a:bodyPr/>
-                    <a:lstStyle/>
-                    <a:p>
-                      <a:pPr algn="ctr" indent="0" marL="0">
-                        <a:buNone/>
-                      </a:pPr>
-                      <a:r>
-                        <a:rPr lang="en-US" sz="900" b="1" dirty="0">
-                          <a:solidFill>
-                            <a:srgbClr val="FFFFFF"/>
-                          </a:solidFill>
-                          <a:latin typeface="Microsoft YaHei" pitchFamily="34" charset="0"/>
-                          <a:ea typeface="Microsoft YaHei" pitchFamily="34" charset="-122"/>
-                          <a:cs typeface="Microsoft YaHei" pitchFamily="34" charset="-120"/>
-                        </a:rPr>
-                        <a:t>技术壁垒</a:t>
-                      </a:r>
-                      <a:endParaRPr lang="en-US" sz="900" dirty="0">
-                        <a:latin typeface="Microsoft YaHei" charset="0"/>
-                        <a:ea typeface="Microsoft YaHei" charset="0"/>
-                        <a:cs typeface="Microsoft YaHei" charset="0"/>
-                      </a:endParaRPr>
-                    </a:p>
-                  </a:txBody>
-                  <a:tcPr marL="91440" marR="91440" marT="45720" marB="45720">
-                    <a:lnL w="6350" cap="flat" cmpd="sng" algn="ctr">
-                      <a:solidFill>
-                        <a:srgbClr val="0077B6"/>
-                      </a:solidFill>
-                      <a:prstDash val="solid"/>
-                      <a:round/>
-                      <a:headEnd type="none" w="med" len="med"/>
-                      <a:tailEnd type="none" w="med" len="med"/>
-                    </a:lnL>
-                    <a:lnR w="6350" cap="flat" cmpd="sng" algn="ctr">
-                      <a:solidFill>
-                        <a:srgbClr val="0077B6"/>
-                      </a:solidFill>
-                      <a:prstDash val="solid"/>
-                      <a:round/>
-                      <a:headEnd type="none" w="med" len="med"/>
-                      <a:tailEnd type="none" w="med" len="med"/>
-                    </a:lnR>
-                    <a:lnT w="6350" cap="flat" cmpd="sng" algn="ctr">
-                      <a:solidFill>
-                        <a:srgbClr val="0077B6"/>
-                      </a:solidFill>
-                      <a:prstDash val="solid"/>
-                      <a:round/>
-                      <a:headEnd type="none" w="med" len="med"/>
-                      <a:tailEnd type="none" w="med" len="med"/>
-                    </a:lnT>
-                    <a:lnB w="6350" cap="flat" cmpd="sng" algn="ctr">
-                      <a:solidFill>
-                        <a:srgbClr val="0077B6"/>
-                      </a:solidFill>
-                      <a:prstDash val="solid"/>
-                      <a:round/>
-                      <a:headEnd type="none" w="med" len="med"/>
-                      <a:tailEnd type="none" w="med" len="med"/>
-                    </a:lnB>
-                    <a:solidFill>
-                      <a:srgbClr val="03045E"/>
-                    </a:solidFill>
-                  </a:tcPr>
-                </a:tc>
-                <a:tc>
-                  <a:txBody>
-                    <a:bodyPr/>
-                    <a:lstStyle/>
-                    <a:p>
-                      <a:pPr algn="ctr" indent="0" marL="0">
-                        <a:buNone/>
-                      </a:pPr>
-                      <a:r>
-                        <a:rPr lang="en-US" sz="900" b="1" dirty="0">
-                          <a:solidFill>
-                            <a:srgbClr val="FFFFFF"/>
-                          </a:solidFill>
-                          <a:latin typeface="Microsoft YaHei" pitchFamily="34" charset="0"/>
-                          <a:ea typeface="Microsoft YaHei" pitchFamily="34" charset="-122"/>
-                          <a:cs typeface="Microsoft YaHei" pitchFamily="34" charset="-120"/>
-                        </a:rPr>
-                        <a:t>竞争烈度</a:t>
-                      </a:r>
-                      <a:endParaRPr lang="en-US" sz="900" dirty="0">
-                        <a:latin typeface="Microsoft YaHei" charset="0"/>
-                        <a:ea typeface="Microsoft YaHei" charset="0"/>
-                        <a:cs typeface="Microsoft YaHei" charset="0"/>
-                      </a:endParaRPr>
-                    </a:p>
-                  </a:txBody>
-                  <a:tcPr marL="91440" marR="91440" marT="45720" marB="45720">
-                    <a:lnL w="6350" cap="flat" cmpd="sng" algn="ctr">
-                      <a:solidFill>
-                        <a:srgbClr val="0077B6"/>
-                      </a:solidFill>
-                      <a:prstDash val="solid"/>
-                      <a:round/>
-                      <a:headEnd type="none" w="med" len="med"/>
-                      <a:tailEnd type="none" w="med" len="med"/>
-                    </a:lnL>
-                    <a:lnR w="6350" cap="flat" cmpd="sng" algn="ctr">
-                      <a:solidFill>
-                        <a:srgbClr val="0077B6"/>
-                      </a:solidFill>
-                      <a:prstDash val="solid"/>
-                      <a:round/>
-                      <a:headEnd type="none" w="med" len="med"/>
-                      <a:tailEnd type="none" w="med" len="med"/>
-                    </a:lnR>
-                    <a:lnT w="6350" cap="flat" cmpd="sng" algn="ctr">
-                      <a:solidFill>
-                        <a:srgbClr val="0077B6"/>
-                      </a:solidFill>
-                      <a:prstDash val="solid"/>
-                      <a:round/>
-                      <a:headEnd type="none" w="med" len="med"/>
-                      <a:tailEnd type="none" w="med" len="med"/>
-                    </a:lnT>
-                    <a:lnB w="6350" cap="flat" cmpd="sng" algn="ctr">
-                      <a:solidFill>
-                        <a:srgbClr val="0077B6"/>
-                      </a:solidFill>
-                      <a:prstDash val="solid"/>
-                      <a:round/>
-                      <a:headEnd type="none" w="med" len="med"/>
-                      <a:tailEnd type="none" w="med" len="med"/>
-                    </a:lnB>
-                    <a:solidFill>
-                      <a:srgbClr val="03045E"/>
-                    </a:solidFill>
-                  </a:tcPr>
-                </a:tc>
-                <a:tc>
-                  <a:txBody>
-                    <a:bodyPr/>
-                    <a:lstStyle/>
-                    <a:p>
-                      <a:pPr algn="ctr" indent="0" marL="0">
-                        <a:buNone/>
-                      </a:pPr>
-                      <a:r>
-                        <a:rPr lang="en-US" sz="900" b="1" dirty="0">
-                          <a:solidFill>
-                            <a:srgbClr val="FFFFFF"/>
-                          </a:solidFill>
-                          <a:latin typeface="Microsoft YaHei" pitchFamily="34" charset="0"/>
-                          <a:ea typeface="Microsoft YaHei" pitchFamily="34" charset="-122"/>
-                          <a:cs typeface="Microsoft YaHei" pitchFamily="34" charset="-120"/>
-                        </a:rPr>
-                        <a:t>差异化空间</a:t>
-                      </a:r>
-                      <a:endParaRPr lang="en-US" sz="900" dirty="0">
-                        <a:latin typeface="Microsoft YaHei" charset="0"/>
-                        <a:ea typeface="Microsoft YaHei" charset="0"/>
-                        <a:cs typeface="Microsoft YaHei" charset="0"/>
-                      </a:endParaRPr>
-                    </a:p>
-                  </a:txBody>
-                  <a:tcPr marL="91440" marR="91440" marT="45720" marB="45720">
-                    <a:lnL w="6350" cap="flat" cmpd="sng" algn="ctr">
-                      <a:solidFill>
-                        <a:srgbClr val="0077B6"/>
-                      </a:solidFill>
-                      <a:prstDash val="solid"/>
-                      <a:round/>
-                      <a:headEnd type="none" w="med" len="med"/>
-                      <a:tailEnd type="none" w="med" len="med"/>
-                    </a:lnL>
-                    <a:lnR w="6350" cap="flat" cmpd="sng" algn="ctr">
-                      <a:solidFill>
-                        <a:srgbClr val="0077B6"/>
-                      </a:solidFill>
-                      <a:prstDash val="solid"/>
-                      <a:round/>
-                      <a:headEnd type="none" w="med" len="med"/>
-                      <a:tailEnd type="none" w="med" len="med"/>
-                    </a:lnR>
-                    <a:lnT w="6350" cap="flat" cmpd="sng" algn="ctr">
-                      <a:solidFill>
-                        <a:srgbClr val="0077B6"/>
-                      </a:solidFill>
-                      <a:prstDash val="solid"/>
-                      <a:round/>
-                      <a:headEnd type="none" w="med" len="med"/>
-                      <a:tailEnd type="none" w="med" len="med"/>
-                    </a:lnT>
-                    <a:lnB w="6350" cap="flat" cmpd="sng" algn="ctr">
-                      <a:solidFill>
-                        <a:srgbClr val="0077B6"/>
-                      </a:solidFill>
-                      <a:prstDash val="solid"/>
-                      <a:round/>
-                      <a:headEnd type="none" w="med" len="med"/>
-                      <a:tailEnd type="none" w="med" len="med"/>
-                    </a:lnB>
-                    <a:solidFill>
-                      <a:srgbClr val="03045E"/>
-                    </a:solidFill>
-                  </a:tcPr>
-                </a:tc>
-                <a:tc>
-                  <a:txBody>
-                    <a:bodyPr/>
-                    <a:lstStyle/>
-                    <a:p>
-                      <a:pPr algn="ctr" indent="0" marL="0">
-                        <a:buNone/>
-                      </a:pPr>
-                      <a:r>
-                        <a:rPr lang="en-US" sz="900" b="1" dirty="0">
-                          <a:solidFill>
-                            <a:srgbClr val="FFFFFF"/>
-                          </a:solidFill>
-                          <a:latin typeface="Microsoft YaHei" pitchFamily="34" charset="0"/>
-                          <a:ea typeface="Microsoft YaHei" pitchFamily="34" charset="-122"/>
-                          <a:cs typeface="Microsoft YaHei" pitchFamily="34" charset="-120"/>
-                        </a:rPr>
-                        <a:t>海悟策略</a:t>
-                      </a:r>
-                      <a:endParaRPr lang="en-US" sz="900" dirty="0">
-                        <a:latin typeface="Microsoft YaHei" charset="0"/>
-                        <a:ea typeface="Microsoft YaHei" charset="0"/>
-                        <a:cs typeface="Microsoft YaHei" charset="0"/>
-                      </a:endParaRPr>
-                    </a:p>
-                  </a:txBody>
-                  <a:tcPr marL="91440" marR="91440" marT="45720" marB="45720">
-                    <a:lnL w="6350" cap="flat" cmpd="sng" algn="ctr">
-                      <a:solidFill>
-                        <a:srgbClr val="0077B6"/>
-                      </a:solidFill>
-                      <a:prstDash val="solid"/>
-                      <a:round/>
-                      <a:headEnd type="none" w="med" len="med"/>
-                      <a:tailEnd type="none" w="med" len="med"/>
-                    </a:lnL>
-                    <a:lnR w="6350" cap="flat" cmpd="sng" algn="ctr">
-                      <a:solidFill>
-                        <a:srgbClr val="0077B6"/>
-                      </a:solidFill>
-                      <a:prstDash val="solid"/>
-                      <a:round/>
-                      <a:headEnd type="none" w="med" len="med"/>
-                      <a:tailEnd type="none" w="med" len="med"/>
-                    </a:lnR>
-                    <a:lnT w="6350" cap="flat" cmpd="sng" algn="ctr">
-                      <a:solidFill>
-                        <a:srgbClr val="0077B6"/>
-                      </a:solidFill>
-                      <a:prstDash val="solid"/>
-                      <a:round/>
-                      <a:headEnd type="none" w="med" len="med"/>
-                      <a:tailEnd type="none" w="med" len="med"/>
-                    </a:lnT>
-                    <a:lnB w="6350" cap="flat" cmpd="sng" algn="ctr">
-                      <a:solidFill>
-                        <a:srgbClr val="0077B6"/>
-                      </a:solidFill>
-                      <a:prstDash val="solid"/>
-                      <a:round/>
-                      <a:headEnd type="none" w="med" len="med"/>
-                      <a:tailEnd type="none" w="med" len="med"/>
-                    </a:lnB>
-                    <a:solidFill>
-                      <a:srgbClr val="03045E"/>
-                    </a:solidFill>
-                  </a:tcPr>
-                </a:tc>
-                <a:tc>
-                  <a:txBody>
-                    <a:bodyPr/>
-                    <a:lstStyle/>
-                    <a:p>
-                      <a:pPr algn="ctr" indent="0" marL="0">
-                        <a:buNone/>
-                      </a:pPr>
-                      <a:r>
-                        <a:rPr lang="en-US" sz="900" b="1" dirty="0">
-                          <a:solidFill>
-                            <a:srgbClr val="FFFFFF"/>
-                          </a:solidFill>
-                          <a:latin typeface="Arial" pitchFamily="34" charset="0"/>
-                          <a:ea typeface="Arial" pitchFamily="34" charset="-122"/>
-                          <a:cs typeface="Arial" pitchFamily="34" charset="-120"/>
-                        </a:rPr>
-                        <a:t>启动时间</a:t>
-                      </a:r>
-                      <a:endParaRPr lang="en-US" sz="900" dirty="0">
-                        <a:latin typeface="Arial" charset="0"/>
-                        <a:ea typeface="Arial" charset="0"/>
-                        <a:cs typeface="Arial" charset="0"/>
-                      </a:endParaRPr>
-                    </a:p>
-                  </a:txBody>
-                  <a:tcPr marL="91440" marR="91440" marT="45720" marB="45720">
-                    <a:lnL w="6350" cap="flat" cmpd="sng" algn="ctr">
-                      <a:solidFill>
-                        <a:srgbClr val="0077B6"/>
-                      </a:solidFill>
-                      <a:prstDash val="solid"/>
-                      <a:round/>
-                      <a:headEnd type="none" w="med" len="med"/>
-                      <a:tailEnd type="none" w="med" len="med"/>
-                    </a:lnL>
-                    <a:lnR w="6350" cap="flat" cmpd="sng" algn="ctr">
-                      <a:solidFill>
-                        <a:srgbClr val="0077B6"/>
-                      </a:solidFill>
-                      <a:prstDash val="solid"/>
-                      <a:round/>
-                      <a:headEnd type="none" w="med" len="med"/>
-                      <a:tailEnd type="none" w="med" len="med"/>
-                    </a:lnR>
-                    <a:lnT w="6350" cap="flat" cmpd="sng" algn="ctr">
-                      <a:solidFill>
-                        <a:srgbClr val="0077B6"/>
-                      </a:solidFill>
-                      <a:prstDash val="solid"/>
-                      <a:round/>
-                      <a:headEnd type="none" w="med" len="med"/>
-                      <a:tailEnd type="none" w="med" len="med"/>
-                    </a:lnT>
-                    <a:lnB w="6350" cap="flat" cmpd="sng" algn="ctr">
-                      <a:solidFill>
-                        <a:srgbClr val="0077B6"/>
-                      </a:solidFill>
-                      <a:prstDash val="solid"/>
-                      <a:round/>
-                      <a:headEnd type="none" w="med" len="med"/>
-                      <a:tailEnd type="none" w="med" len="med"/>
-                    </a:lnB>
-                    <a:solidFill>
-                      <a:srgbClr val="03045E"/>
-                    </a:solidFill>
-                  </a:tcPr>
-                </a:tc>
-              </a:tr>
-              <a:tr h="320040">
-                <a:tc>
-                  <a:txBody>
-                    <a:bodyPr/>
-                    <a:lstStyle/>
-                    <a:p>
-                      <a:pPr indent="0" marL="0">
-                        <a:buNone/>
-                      </a:pPr>
-                      <a:endParaRPr lang="en-US" sz="1200" dirty="0"/>
-                    </a:p>
-                  </a:txBody>
-                  <a:tcPr marL="91440" marR="91440" marT="45720" marB="45720">
-                    <a:lnL w="6350" cap="flat" cmpd="sng" algn="ctr">
-                      <a:solidFill>
-                        <a:srgbClr val="0077B6"/>
-                      </a:solidFill>
-                      <a:prstDash val="solid"/>
-                      <a:round/>
-                      <a:headEnd type="none" w="med" len="med"/>
-                      <a:tailEnd type="none" w="med" len="med"/>
-                    </a:lnL>
-                    <a:lnR w="6350" cap="flat" cmpd="sng" algn="ctr">
-                      <a:solidFill>
-                        <a:srgbClr val="0077B6"/>
-                      </a:solidFill>
-                      <a:prstDash val="solid"/>
-                      <a:round/>
-                      <a:headEnd type="none" w="med" len="med"/>
-                      <a:tailEnd type="none" w="med" len="med"/>
-                    </a:lnR>
-                    <a:lnT w="6350" cap="flat" cmpd="sng" algn="ctr">
-                      <a:solidFill>
-                        <a:srgbClr val="0077B6"/>
-                      </a:solidFill>
-                      <a:prstDash val="solid"/>
-                      <a:round/>
-                      <a:headEnd type="none" w="med" len="med"/>
-                      <a:tailEnd type="none" w="med" len="med"/>
-                    </a:lnT>
-                    <a:lnB w="6350" cap="flat" cmpd="sng" algn="ctr">
-                      <a:solidFill>
-                        <a:srgbClr val="0077B6"/>
-                      </a:solidFill>
-                      <a:prstDash val="solid"/>
-                      <a:round/>
-                      <a:headEnd type="none" w="med" len="med"/>
-                      <a:tailEnd type="none" w="med" len="med"/>
-                    </a:lnB>
-                  </a:tcPr>
-                </a:tc>
-                <a:tc>
-                  <a:txBody>
-                    <a:bodyPr/>
-                    <a:lstStyle/>
-                    <a:p>
-                      <a:pPr indent="0" marL="0">
-                        <a:buNone/>
-                      </a:pPr>
-                      <a:endParaRPr lang="en-US" sz="1200" dirty="0"/>
-                    </a:p>
-                  </a:txBody>
-                  <a:tcPr marL="91440" marR="91440" marT="45720" marB="45720">
-                    <a:lnL w="6350" cap="flat" cmpd="sng" algn="ctr">
-                      <a:solidFill>
-                        <a:srgbClr val="0077B6"/>
-                      </a:solidFill>
-                      <a:prstDash val="solid"/>
-                      <a:round/>
-                      <a:headEnd type="none" w="med" len="med"/>
-                      <a:tailEnd type="none" w="med" len="med"/>
-                    </a:lnL>
-                    <a:lnR w="6350" cap="flat" cmpd="sng" algn="ctr">
-                      <a:solidFill>
-                        <a:srgbClr val="0077B6"/>
-                      </a:solidFill>
-                      <a:prstDash val="solid"/>
-                      <a:round/>
-                      <a:headEnd type="none" w="med" len="med"/>
-                      <a:tailEnd type="none" w="med" len="med"/>
-                    </a:lnR>
-                    <a:lnT w="6350" cap="flat" cmpd="sng" algn="ctr">
-                      <a:solidFill>
-                        <a:srgbClr val="0077B6"/>
-                      </a:solidFill>
-                      <a:prstDash val="solid"/>
-                      <a:round/>
-                      <a:headEnd type="none" w="med" len="med"/>
-                      <a:tailEnd type="none" w="med" len="med"/>
-                    </a:lnT>
-                    <a:lnB w="6350" cap="flat" cmpd="sng" algn="ctr">
-                      <a:solidFill>
-                        <a:srgbClr val="0077B6"/>
-                      </a:solidFill>
-                      <a:prstDash val="solid"/>
-                      <a:round/>
-                      <a:headEnd type="none" w="med" len="med"/>
-                      <a:tailEnd type="none" w="med" len="med"/>
-                    </a:lnB>
-                  </a:tcPr>
-                </a:tc>
-                <a:tc>
-                  <a:txBody>
-                    <a:bodyPr/>
-                    <a:lstStyle/>
-                    <a:p>
-                      <a:pPr indent="0" marL="0">
-                        <a:buNone/>
-                      </a:pPr>
-                      <a:endParaRPr lang="en-US" sz="1200" dirty="0"/>
-                    </a:p>
-                  </a:txBody>
-                  <a:tcPr marL="91440" marR="91440" marT="45720" marB="45720">
-                    <a:lnL w="6350" cap="flat" cmpd="sng" algn="ctr">
-                      <a:solidFill>
-                        <a:srgbClr val="0077B6"/>
-                      </a:solidFill>
-                      <a:prstDash val="solid"/>
-                      <a:round/>
-                      <a:headEnd type="none" w="med" len="med"/>
-                      <a:tailEnd type="none" w="med" len="med"/>
-                    </a:lnL>
-                    <a:lnR w="6350" cap="flat" cmpd="sng" algn="ctr">
-                      <a:solidFill>
-                        <a:srgbClr val="0077B6"/>
-                      </a:solidFill>
-                      <a:prstDash val="solid"/>
-                      <a:round/>
-                      <a:headEnd type="none" w="med" len="med"/>
-                      <a:tailEnd type="none" w="med" len="med"/>
-                    </a:lnR>
-                    <a:lnT w="6350" cap="flat" cmpd="sng" algn="ctr">
-                      <a:solidFill>
-                        <a:srgbClr val="0077B6"/>
-                      </a:solidFill>
-                      <a:prstDash val="solid"/>
-                      <a:round/>
-                      <a:headEnd type="none" w="med" len="med"/>
-                      <a:tailEnd type="none" w="med" len="med"/>
-                    </a:lnT>
-                    <a:lnB w="6350" cap="flat" cmpd="sng" algn="ctr">
-                      <a:solidFill>
-                        <a:srgbClr val="0077B6"/>
-                      </a:solidFill>
-                      <a:prstDash val="solid"/>
-                      <a:round/>
-                      <a:headEnd type="none" w="med" len="med"/>
-                      <a:tailEnd type="none" w="med" len="med"/>
-                    </a:lnB>
-                  </a:tcPr>
-                </a:tc>
-                <a:tc>
-                  <a:txBody>
-                    <a:bodyPr/>
-                    <a:lstStyle/>
-                    <a:p>
-                      <a:pPr indent="0" marL="0">
-                        <a:buNone/>
-                      </a:pPr>
-                      <a:endParaRPr lang="en-US" sz="1200" dirty="0"/>
-                    </a:p>
-                  </a:txBody>
-                  <a:tcPr marL="91440" marR="91440" marT="45720" marB="45720">
-                    <a:lnL w="6350" cap="flat" cmpd="sng" algn="ctr">
-                      <a:solidFill>
-                        <a:srgbClr val="0077B6"/>
-                      </a:solidFill>
-                      <a:prstDash val="solid"/>
-                      <a:round/>
-                      <a:headEnd type="none" w="med" len="med"/>
-                      <a:tailEnd type="none" w="med" len="med"/>
-                    </a:lnL>
-                    <a:lnR w="6350" cap="flat" cmpd="sng" algn="ctr">
-                      <a:solidFill>
-                        <a:srgbClr val="0077B6"/>
-                      </a:solidFill>
-                      <a:prstDash val="solid"/>
-                      <a:round/>
-                      <a:headEnd type="none" w="med" len="med"/>
-                      <a:tailEnd type="none" w="med" len="med"/>
-                    </a:lnR>
-                    <a:lnT w="6350" cap="flat" cmpd="sng" algn="ctr">
-                      <a:solidFill>
-                        <a:srgbClr val="0077B6"/>
-                      </a:solidFill>
-                      <a:prstDash val="solid"/>
-                      <a:round/>
-                      <a:headEnd type="none" w="med" len="med"/>
-                      <a:tailEnd type="none" w="med" len="med"/>
-                    </a:lnT>
-                    <a:lnB w="6350" cap="flat" cmpd="sng" algn="ctr">
-                      <a:solidFill>
-                        <a:srgbClr val="0077B6"/>
-                      </a:solidFill>
-                      <a:prstDash val="solid"/>
-                      <a:round/>
-                      <a:headEnd type="none" w="med" len="med"/>
-                      <a:tailEnd type="none" w="med" len="med"/>
-                    </a:lnB>
-                  </a:tcPr>
-                </a:tc>
-                <a:tc>
-                  <a:txBody>
-                    <a:bodyPr/>
-                    <a:lstStyle/>
-                    <a:p>
-                      <a:pPr indent="0" marL="0">
-                        <a:buNone/>
-                      </a:pPr>
-                      <a:endParaRPr lang="en-US" sz="1200" dirty="0"/>
-                    </a:p>
-                  </a:txBody>
-                  <a:tcPr marL="91440" marR="91440" marT="45720" marB="45720">
-                    <a:lnL w="6350" cap="flat" cmpd="sng" algn="ctr">
-                      <a:solidFill>
-                        <a:srgbClr val="0077B6"/>
-                      </a:solidFill>
-                      <a:prstDash val="solid"/>
-                      <a:round/>
-                      <a:headEnd type="none" w="med" len="med"/>
-                      <a:tailEnd type="none" w="med" len="med"/>
-                    </a:lnL>
-                    <a:lnR w="6350" cap="flat" cmpd="sng" algn="ctr">
-                      <a:solidFill>
-                        <a:srgbClr val="0077B6"/>
-                      </a:solidFill>
-                      <a:prstDash val="solid"/>
-                      <a:round/>
-                      <a:headEnd type="none" w="med" len="med"/>
-                      <a:tailEnd type="none" w="med" len="med"/>
-                    </a:lnR>
-                    <a:lnT w="6350" cap="flat" cmpd="sng" algn="ctr">
-                      <a:solidFill>
-                        <a:srgbClr val="0077B6"/>
-                      </a:solidFill>
-                      <a:prstDash val="solid"/>
-                      <a:round/>
-                      <a:headEnd type="none" w="med" len="med"/>
-                      <a:tailEnd type="none" w="med" len="med"/>
-                    </a:lnT>
-                    <a:lnB w="6350" cap="flat" cmpd="sng" algn="ctr">
-                      <a:solidFill>
-                        <a:srgbClr val="0077B6"/>
-                      </a:solidFill>
-                      <a:prstDash val="solid"/>
-                      <a:round/>
-                      <a:headEnd type="none" w="med" len="med"/>
-                      <a:tailEnd type="none" w="med" len="med"/>
-                    </a:lnB>
-                  </a:tcPr>
-                </a:tc>
-                <a:tc>
-                  <a:txBody>
-                    <a:bodyPr/>
-                    <a:lstStyle/>
-                    <a:p>
-                      <a:pPr indent="0" marL="0">
-                        <a:buNone/>
-                      </a:pPr>
-                      <a:endParaRPr lang="en-US" sz="1200" dirty="0"/>
-                    </a:p>
-                  </a:txBody>
-                  <a:tcPr marL="91440" marR="91440" marT="45720" marB="45720">
-                    <a:lnL w="6350" cap="flat" cmpd="sng" algn="ctr">
-                      <a:solidFill>
-                        <a:srgbClr val="0077B6"/>
-                      </a:solidFill>
-                      <a:prstDash val="solid"/>
-                      <a:round/>
-                      <a:headEnd type="none" w="med" len="med"/>
-                      <a:tailEnd type="none" w="med" len="med"/>
-                    </a:lnL>
-                    <a:lnR w="6350" cap="flat" cmpd="sng" algn="ctr">
-                      <a:solidFill>
-                        <a:srgbClr val="0077B6"/>
-                      </a:solidFill>
-                      <a:prstDash val="solid"/>
-                      <a:round/>
-                      <a:headEnd type="none" w="med" len="med"/>
-                      <a:tailEnd type="none" w="med" len="med"/>
-                    </a:lnR>
-                    <a:lnT w="6350" cap="flat" cmpd="sng" algn="ctr">
-                      <a:solidFill>
-                        <a:srgbClr val="0077B6"/>
-                      </a:solidFill>
-                      <a:prstDash val="solid"/>
-                      <a:round/>
-                      <a:headEnd type="none" w="med" len="med"/>
-                      <a:tailEnd type="none" w="med" len="med"/>
-                    </a:lnT>
-                    <a:lnB w="6350" cap="flat" cmpd="sng" algn="ctr">
-                      <a:solidFill>
-                        <a:srgbClr val="0077B6"/>
-                      </a:solidFill>
-                      <a:prstDash val="solid"/>
-                      <a:round/>
-                      <a:headEnd type="none" w="med" len="med"/>
-                      <a:tailEnd type="none" w="med" len="med"/>
-                    </a:lnB>
-                  </a:tcPr>
-                </a:tc>
-                <a:tc>
-                  <a:txBody>
-                    <a:bodyPr/>
-                    <a:lstStyle/>
-                    <a:p>
-                      <a:pPr indent="0" marL="0">
-                        <a:buNone/>
-                      </a:pPr>
-                      <a:endParaRPr lang="en-US" sz="1200" dirty="0"/>
-                    </a:p>
-                  </a:txBody>
-                  <a:tcPr marL="91440" marR="91440" marT="45720" marB="45720">
-                    <a:lnL w="6350" cap="flat" cmpd="sng" algn="ctr">
-                      <a:solidFill>
-                        <a:srgbClr val="0077B6"/>
-                      </a:solidFill>
-                      <a:prstDash val="solid"/>
-                      <a:round/>
-                      <a:headEnd type="none" w="med" len="med"/>
-                      <a:tailEnd type="none" w="med" len="med"/>
-                    </a:lnL>
-                    <a:lnR w="6350" cap="flat" cmpd="sng" algn="ctr">
-                      <a:solidFill>
-                        <a:srgbClr val="0077B6"/>
-                      </a:solidFill>
-                      <a:prstDash val="solid"/>
-                      <a:round/>
-                      <a:headEnd type="none" w="med" len="med"/>
-                      <a:tailEnd type="none" w="med" len="med"/>
-                    </a:lnR>
-                    <a:lnT w="6350" cap="flat" cmpd="sng" algn="ctr">
-                      <a:solidFill>
-                        <a:srgbClr val="0077B6"/>
-                      </a:solidFill>
-                      <a:prstDash val="solid"/>
-                      <a:round/>
-                      <a:headEnd type="none" w="med" len="med"/>
-                      <a:tailEnd type="none" w="med" len="med"/>
-                    </a:lnT>
-                    <a:lnB w="6350" cap="flat" cmpd="sng" algn="ctr">
-                      <a:solidFill>
-                        <a:srgbClr val="0077B6"/>
-                      </a:solidFill>
-                      <a:prstDash val="solid"/>
-                      <a:round/>
-                      <a:headEnd type="none" w="med" len="med"/>
-                      <a:tailEnd type="none" w="med" len="med"/>
-                    </a:lnB>
-                  </a:tcPr>
-                </a:tc>
-              </a:tr>
-            </a:tbl>
-          </a:graphicData>
-        </a:graphic>
-      </p:graphicFrame>
-      <p:sp>
-        <p:nvSpPr>
-          <p:cNvPr id="5" name="Text 2"/>
-          <p:cNvSpPr/>
-          <p:nvPr/>
-        </p:nvSpPr>
-        <p:spPr>
-          <a:xfrm>
-            <a:off x="457200" y="3840480"/>
-            <a:ext cx="8229600" cy="365760"/>
-          </a:xfrm>
-          <a:prstGeom prst="rect">
-            <a:avLst/>
-          </a:prstGeom>
-          <a:noFill/>
-          <a:ln/>
-        </p:spPr>
-        <p:txBody>
-          <a:bodyPr wrap="square" rtlCol="0" anchor="ctr"/>
-          <a:lstStyle/>
-          <a:p>
-            <a:pPr indent="0" marL="0">
-              <a:buNone/>
-            </a:pPr>
-            <a:r>
-              <a:rPr lang="en-US" sz="1100" b="1" dirty="0">
-                <a:solidFill>
-                  <a:srgbClr val="00B4D8"/>
-                </a:solidFill>
-                <a:latin typeface="Microsoft YaHei" pitchFamily="34" charset="0"/>
-                <a:ea typeface="Microsoft YaHei" pitchFamily="34" charset="-122"/>
-                <a:cs typeface="Microsoft YaHei" pitchFamily="34" charset="-120"/>
-              </a:rPr>
-              <a:t>⚡ 2026核心动作: ① Manifold送样H3C/浪潮(¥50M)  ② 电源冷板研发立项(2027蓝海爆量¥300M)</a:t>
-            </a:r>
-            <a:endParaRPr lang="en-US" sz="1100" dirty="0"/>
-          </a:p>
-        </p:txBody>
-      </p:sp>
-      <p:sp>
-        <p:nvSpPr>
-          <p:cNvPr id="6" name="Shape 3"/>
-          <p:cNvSpPr/>
-          <p:nvPr/>
-        </p:nvSpPr>
-        <p:spPr>
-          <a:xfrm>
-            <a:off x="8503920" y="4663440"/>
-            <a:ext cx="365760" cy="365760"/>
-          </a:xfrm>
-          <a:prstGeom prst="oval">
-            <a:avLst/>
-          </a:prstGeom>
-          <a:solidFill>
-            <a:srgbClr val="00B4D8"/>
-          </a:solidFill>
-          <a:ln/>
-        </p:spPr>
-      </p:sp>
-      <p:sp>
-        <p:nvSpPr>
-          <p:cNvPr id="7" name="Text 4"/>
-          <p:cNvSpPr/>
-          <p:nvPr/>
-        </p:nvSpPr>
-        <p:spPr>
-          <a:xfrm>
-            <a:off x="8503920" y="4663440"/>
-            <a:ext cx="365760" cy="365760"/>
-          </a:xfrm>
-          <a:prstGeom prst="rect">
-            <a:avLst/>
-          </a:prstGeom>
-          <a:noFill/>
-          <a:ln/>
-        </p:spPr>
-        <p:txBody>
-          <a:bodyPr wrap="square" rtlCol="0" anchor="ctr"/>
-          <a:lstStyle/>
-          <a:p>
-            <a:pPr algn="ctr" indent="0" marL="0">
-              <a:buNone/>
-            </a:pPr>
-            <a:r>
-              <a:rPr lang="en-US" sz="1000" b="1" dirty="0">
-                <a:solidFill>
-                  <a:srgbClr val="FFFFFF"/>
-                </a:solidFill>
-                <a:latin typeface="Arial" pitchFamily="34" charset="0"/>
-                <a:ea typeface="Arial" pitchFamily="34" charset="-122"/>
-                <a:cs typeface="Arial" pitchFamily="34" charset="-120"/>
-              </a:rPr>
-              <a:t>32</a:t>
-            </a:r>
-            <a:endParaRPr lang="en-US" sz="1000" dirty="0"/>
-          </a:p>
-        </p:txBody>
-      </p:sp>
-      <p:sp>
-        <p:nvSpPr>
-          <p:cNvPr id="8" name="Text 5"/>
-          <p:cNvSpPr/>
-          <p:nvPr/>
-        </p:nvSpPr>
-        <p:spPr>
-          <a:xfrm>
-            <a:off x="457200" y="4754880"/>
-            <a:ext cx="4572000" cy="274320"/>
-          </a:xfrm>
-          <a:prstGeom prst="rect">
-            <a:avLst/>
-          </a:prstGeom>
-          <a:noFill/>
-          <a:ln/>
-        </p:spPr>
-        <p:txBody>
-          <a:bodyPr wrap="square" rtlCol="0" anchor="ctr"/>
-          <a:lstStyle/>
-          <a:p>
-            <a:pPr indent="0" marL="0">
-              <a:buNone/>
-            </a:pPr>
-            <a:r>
-              <a:rPr lang="en-US" sz="700" dirty="0">
-                <a:solidFill>
-                  <a:srgbClr val="0077B6"/>
-                </a:solidFill>
-                <a:latin typeface="Microsoft YaHei" pitchFamily="34" charset="0"/>
-                <a:ea typeface="Microsoft YaHei" pitchFamily="34" charset="-122"/>
-                <a:cs typeface="Microsoft YaHei" pitchFamily="34" charset="-120"/>
-              </a:rPr>
-              <a:t>海悟科技 | 机柜级液冷战略 | 2026-05</a:t>
-            </a:r>
-            <a:endParaRPr lang="en-US" sz="700" dirty="0"/>
-          </a:p>
-        </p:txBody>
-      </p:sp>
     </p:spTree>
   </p:cSld>
   <p:clrMapOvr>

</xml_diff>